<commit_message>
update presentation, finish script
</commit_message>
<xml_diff>
--- a/docs/Presentatation/2026_Б_ПІ_ПЗПІ-22-1_Токар_Д_Ю.pptx
+++ b/docs/Presentatation/2026_Б_ПІ_ПЗПІ-22-1_Токар_Д_Ю.pptx
@@ -139,6 +139,9 @@
         </p14:section>
       </p14:sectionLst>
     </p:ext>
+    <p:ext uri="{EFAFB233-063F-42B5-8137-9DF3F51BA10A}">
+      <p15:sldGuideLst xmlns:p15="http://schemas.microsoft.com/office/powerpoint/2012/main"/>
+    </p:ext>
   </p:extLst>
 </p:presentation>
 </file>
@@ -225,7 +228,7 @@
           <a:p>
             <a:fld id="{F33178FF-A00C-460C-AA19-334A29EE492E}" type="datetimeFigureOut">
               <a:rPr lang="en-US" smtClean="0"/>
-              <a:t>6/18/2026</a:t>
+              <a:t>6/20/2026</a:t>
             </a:fld>
             <a:endParaRPr lang="en-US"/>
           </a:p>
@@ -624,7 +627,7 @@
           <a:p>
             <a:fld id="{BFDA3913-F354-4F01-B5FC-93C56F8E9E4F}" type="datetimeFigureOut">
               <a:rPr lang="en-US" smtClean="0"/>
-              <a:t>6/18/2026</a:t>
+              <a:t>6/20/2026</a:t>
             </a:fld>
             <a:endParaRPr lang="en-US"/>
           </a:p>
@@ -794,7 +797,7 @@
           <a:p>
             <a:fld id="{BFDA3913-F354-4F01-B5FC-93C56F8E9E4F}" type="datetimeFigureOut">
               <a:rPr lang="en-US" smtClean="0"/>
-              <a:t>6/18/2026</a:t>
+              <a:t>6/20/2026</a:t>
             </a:fld>
             <a:endParaRPr lang="en-US"/>
           </a:p>
@@ -974,7 +977,7 @@
           <a:p>
             <a:fld id="{BFDA3913-F354-4F01-B5FC-93C56F8E9E4F}" type="datetimeFigureOut">
               <a:rPr lang="en-US" smtClean="0"/>
-              <a:t>6/18/2026</a:t>
+              <a:t>6/20/2026</a:t>
             </a:fld>
             <a:endParaRPr lang="en-US"/>
           </a:p>
@@ -1144,7 +1147,7 @@
           <a:p>
             <a:fld id="{BFDA3913-F354-4F01-B5FC-93C56F8E9E4F}" type="datetimeFigureOut">
               <a:rPr lang="en-US" smtClean="0"/>
-              <a:t>6/18/2026</a:t>
+              <a:t>6/20/2026</a:t>
             </a:fld>
             <a:endParaRPr lang="en-US"/>
           </a:p>
@@ -1390,7 +1393,7 @@
           <a:p>
             <a:fld id="{BFDA3913-F354-4F01-B5FC-93C56F8E9E4F}" type="datetimeFigureOut">
               <a:rPr lang="en-US" smtClean="0"/>
-              <a:t>6/18/2026</a:t>
+              <a:t>6/20/2026</a:t>
             </a:fld>
             <a:endParaRPr lang="en-US"/>
           </a:p>
@@ -1622,7 +1625,7 @@
           <a:p>
             <a:fld id="{BFDA3913-F354-4F01-B5FC-93C56F8E9E4F}" type="datetimeFigureOut">
               <a:rPr lang="en-US" smtClean="0"/>
-              <a:t>6/18/2026</a:t>
+              <a:t>6/20/2026</a:t>
             </a:fld>
             <a:endParaRPr lang="en-US"/>
           </a:p>
@@ -1989,7 +1992,7 @@
           <a:p>
             <a:fld id="{BFDA3913-F354-4F01-B5FC-93C56F8E9E4F}" type="datetimeFigureOut">
               <a:rPr lang="en-US" smtClean="0"/>
-              <a:t>6/18/2026</a:t>
+              <a:t>6/20/2026</a:t>
             </a:fld>
             <a:endParaRPr lang="en-US"/>
           </a:p>
@@ -2107,7 +2110,7 @@
           <a:p>
             <a:fld id="{BFDA3913-F354-4F01-B5FC-93C56F8E9E4F}" type="datetimeFigureOut">
               <a:rPr lang="en-US" smtClean="0"/>
-              <a:t>6/18/2026</a:t>
+              <a:t>6/20/2026</a:t>
             </a:fld>
             <a:endParaRPr lang="en-US"/>
           </a:p>
@@ -2202,7 +2205,7 @@
           <a:p>
             <a:fld id="{BFDA3913-F354-4F01-B5FC-93C56F8E9E4F}" type="datetimeFigureOut">
               <a:rPr lang="en-US" smtClean="0"/>
-              <a:t>6/18/2026</a:t>
+              <a:t>6/20/2026</a:t>
             </a:fld>
             <a:endParaRPr lang="en-US"/>
           </a:p>
@@ -2479,7 +2482,7 @@
           <a:p>
             <a:fld id="{BFDA3913-F354-4F01-B5FC-93C56F8E9E4F}" type="datetimeFigureOut">
               <a:rPr lang="en-US" smtClean="0"/>
-              <a:t>6/18/2026</a:t>
+              <a:t>6/20/2026</a:t>
             </a:fld>
             <a:endParaRPr lang="en-US"/>
           </a:p>
@@ -2732,7 +2735,7 @@
           <a:p>
             <a:fld id="{BFDA3913-F354-4F01-B5FC-93C56F8E9E4F}" type="datetimeFigureOut">
               <a:rPr lang="en-US" smtClean="0"/>
-              <a:t>6/18/2026</a:t>
+              <a:t>6/20/2026</a:t>
             </a:fld>
             <a:endParaRPr lang="en-US"/>
           </a:p>
@@ -2945,7 +2948,7 @@
           <a:p>
             <a:fld id="{BFDA3913-F354-4F01-B5FC-93C56F8E9E4F}" type="datetimeFigureOut">
               <a:rPr lang="en-US" smtClean="0"/>
-              <a:t>6/18/2026</a:t>
+              <a:t>6/20/2026</a:t>
             </a:fld>
             <a:endParaRPr lang="en-US"/>
           </a:p>
@@ -4092,7 +4095,15 @@
           <a:p>
             <a:r>
               <a:rPr lang="ru-RU" sz="3200" dirty="0" smtClean="0"/>
-              <a:t>16 </a:t>
+              <a:t>1</a:t>
+            </a:r>
+            <a:r>
+              <a:rPr lang="en-US" sz="3200" dirty="0" smtClean="0"/>
+              <a:t>3</a:t>
+            </a:r>
+            <a:r>
+              <a:rPr lang="ru-RU" sz="3200" dirty="0" smtClean="0"/>
+              <a:t> </a:t>
             </a:r>
             <a:r>
               <a:rPr lang="ru-RU" sz="3200" dirty="0" err="1" smtClean="0"/>
@@ -7857,25 +7868,11 @@
               <a:t>, </a:t>
             </a:r>
             <a:r>
-              <a:rPr lang="en-US" sz="2200" dirty="0" err="1" smtClean="0">
-                <a:latin typeface="Times New Roman" panose="02020603050405020304" pitchFamily="18" charset="0"/>
-                <a:cs typeface="Times New Roman" panose="02020603050405020304" pitchFamily="18" charset="0"/>
-              </a:rPr>
-              <a:t>Servio</a:t>
-            </a:r>
-            <a:r>
-              <a:rPr lang="uk-UA" sz="2200" dirty="0" smtClean="0">
-                <a:latin typeface="Times New Roman" panose="02020603050405020304" pitchFamily="18" charset="0"/>
-                <a:cs typeface="Times New Roman" panose="02020603050405020304" pitchFamily="18" charset="0"/>
-              </a:rPr>
-              <a:t>,</a:t>
-            </a:r>
-            <a:r>
               <a:rPr lang="en-US" sz="2200" dirty="0" smtClean="0">
                 <a:latin typeface="Times New Roman" panose="02020603050405020304" pitchFamily="18" charset="0"/>
                 <a:cs typeface="Times New Roman" panose="02020603050405020304" pitchFamily="18" charset="0"/>
               </a:rPr>
-              <a:t> Choice QR)</a:t>
+              <a:t>Choice QR)</a:t>
             </a:r>
           </a:p>
           <a:p>
@@ -10037,7 +10034,7 @@
         </p:nvSpPr>
         <p:spPr>
           <a:xfrm rot="5784615" flipH="1" flipV="1">
-            <a:off x="-4978195" y="-940289"/>
+            <a:off x="-5102821" y="-850782"/>
             <a:ext cx="5748994" cy="5833850"/>
           </a:xfrm>
           <a:custGeom>
@@ -11231,8 +11228,8 @@
         </p:nvSpPr>
         <p:spPr>
           <a:xfrm>
-            <a:off x="841826" y="1407099"/>
-            <a:ext cx="10508342" cy="4862870"/>
+            <a:off x="841826" y="1206353"/>
+            <a:ext cx="10508342" cy="5001369"/>
           </a:xfrm>
           <a:prstGeom prst="rect">
             <a:avLst/>
@@ -11245,84 +11242,84 @@
           <a:lstStyle/>
           <a:p>
             <a:r>
-              <a:rPr lang="ru-RU" sz="2200" dirty="0" smtClean="0">
+              <a:rPr lang="ru-RU" sz="2000" dirty="0" smtClean="0">
                 <a:latin typeface="Times New Roman" panose="02020603050405020304" pitchFamily="18" charset="0"/>
                 <a:cs typeface="Times New Roman" panose="02020603050405020304" pitchFamily="18" charset="0"/>
               </a:rPr>
               <a:t>Модель BYOD(</a:t>
             </a:r>
             <a:r>
-              <a:rPr lang="en-US" sz="2200" i="1" dirty="0" smtClean="0">
+              <a:rPr lang="en-US" sz="2000" i="1" dirty="0" smtClean="0">
                 <a:latin typeface="Times New Roman" panose="02020603050405020304" pitchFamily="18" charset="0"/>
                 <a:cs typeface="Times New Roman" panose="02020603050405020304" pitchFamily="18" charset="0"/>
               </a:rPr>
               <a:t>Bring Your Own Device</a:t>
             </a:r>
             <a:r>
-              <a:rPr lang="en-US" sz="2200" dirty="0" smtClean="0">
+              <a:rPr lang="en-US" sz="2000" dirty="0" smtClean="0">
                 <a:latin typeface="Times New Roman" panose="02020603050405020304" pitchFamily="18" charset="0"/>
                 <a:cs typeface="Times New Roman" panose="02020603050405020304" pitchFamily="18" charset="0"/>
               </a:rPr>
               <a:t>)</a:t>
             </a:r>
             <a:r>
-              <a:rPr lang="ru-RU" sz="2200" dirty="0" smtClean="0">
+              <a:rPr lang="ru-RU" sz="2000" dirty="0" smtClean="0">
                 <a:latin typeface="Times New Roman" panose="02020603050405020304" pitchFamily="18" charset="0"/>
                 <a:cs typeface="Times New Roman" panose="02020603050405020304" pitchFamily="18" charset="0"/>
               </a:rPr>
               <a:t> — смартфон гостя як </a:t>
             </a:r>
             <a:r>
-              <a:rPr lang="ru-RU" sz="2200" dirty="0" err="1" smtClean="0">
+              <a:rPr lang="ru-RU" sz="2000" dirty="0" err="1" smtClean="0">
                 <a:latin typeface="Times New Roman" panose="02020603050405020304" pitchFamily="18" charset="0"/>
                 <a:cs typeface="Times New Roman" panose="02020603050405020304" pitchFamily="18" charset="0"/>
               </a:rPr>
               <a:t>персональний</a:t>
             </a:r>
             <a:r>
-              <a:rPr lang="ru-RU" sz="2200" dirty="0" smtClean="0">
+              <a:rPr lang="ru-RU" sz="2000" dirty="0" smtClean="0">
                 <a:latin typeface="Times New Roman" panose="02020603050405020304" pitchFamily="18" charset="0"/>
                 <a:cs typeface="Times New Roman" panose="02020603050405020304" pitchFamily="18" charset="0"/>
               </a:rPr>
               <a:t> </a:t>
             </a:r>
             <a:r>
-              <a:rPr lang="ru-RU" sz="2200" dirty="0" err="1" smtClean="0">
+              <a:rPr lang="ru-RU" sz="2000" dirty="0" err="1" smtClean="0">
                 <a:latin typeface="Times New Roman" panose="02020603050405020304" pitchFamily="18" charset="0"/>
                 <a:cs typeface="Times New Roman" panose="02020603050405020304" pitchFamily="18" charset="0"/>
               </a:rPr>
               <a:t>термінал</a:t>
             </a:r>
             <a:r>
-              <a:rPr lang="ru-RU" sz="2200" dirty="0" smtClean="0">
+              <a:rPr lang="ru-RU" sz="2000" dirty="0" smtClean="0">
                 <a:latin typeface="Times New Roman" panose="02020603050405020304" pitchFamily="18" charset="0"/>
                 <a:cs typeface="Times New Roman" panose="02020603050405020304" pitchFamily="18" charset="0"/>
               </a:rPr>
               <a:t> без </a:t>
             </a:r>
             <a:r>
-              <a:rPr lang="ru-RU" sz="2200" dirty="0" err="1" smtClean="0">
+              <a:rPr lang="ru-RU" sz="2000" dirty="0" err="1" smtClean="0">
                 <a:latin typeface="Times New Roman" panose="02020603050405020304" pitchFamily="18" charset="0"/>
                 <a:cs typeface="Times New Roman" panose="02020603050405020304" pitchFamily="18" charset="0"/>
               </a:rPr>
               <a:t>встановлення</a:t>
             </a:r>
             <a:r>
-              <a:rPr lang="ru-RU" sz="2200" dirty="0" smtClean="0">
+              <a:rPr lang="ru-RU" sz="2000" dirty="0" smtClean="0">
                 <a:latin typeface="Times New Roman" panose="02020603050405020304" pitchFamily="18" charset="0"/>
                 <a:cs typeface="Times New Roman" panose="02020603050405020304" pitchFamily="18" charset="0"/>
               </a:rPr>
               <a:t> </a:t>
             </a:r>
             <a:r>
-              <a:rPr lang="ru-RU" sz="2200" dirty="0" err="1" smtClean="0">
+              <a:rPr lang="ru-RU" sz="2000" dirty="0" err="1" smtClean="0">
                 <a:latin typeface="Times New Roman" panose="02020603050405020304" pitchFamily="18" charset="0"/>
                 <a:cs typeface="Times New Roman" panose="02020603050405020304" pitchFamily="18" charset="0"/>
               </a:rPr>
               <a:t>застосунків</a:t>
             </a:r>
             <a:r>
-              <a:rPr lang="ru-RU" sz="2200" dirty="0" smtClean="0">
+              <a:rPr lang="ru-RU" sz="2000" dirty="0" smtClean="0">
                 <a:latin typeface="Times New Roman" panose="02020603050405020304" pitchFamily="18" charset="0"/>
                 <a:cs typeface="Times New Roman" panose="02020603050405020304" pitchFamily="18" charset="0"/>
               </a:rPr>
@@ -11336,35 +11333,35 @@
               </a:spcBef>
             </a:pPr>
             <a:r>
-              <a:rPr lang="ru-RU" sz="2200" dirty="0">
+              <a:rPr lang="ru-RU" sz="2000" dirty="0">
                 <a:latin typeface="Times New Roman" panose="02020603050405020304" pitchFamily="18" charset="0"/>
                 <a:cs typeface="Times New Roman" panose="02020603050405020304" pitchFamily="18" charset="0"/>
               </a:rPr>
               <a:t>4 </a:t>
             </a:r>
             <a:r>
-              <a:rPr lang="ru-RU" sz="2200" dirty="0" err="1">
+              <a:rPr lang="ru-RU" sz="2000" dirty="0" err="1">
                 <a:latin typeface="Times New Roman" panose="02020603050405020304" pitchFamily="18" charset="0"/>
                 <a:cs typeface="Times New Roman" panose="02020603050405020304" pitchFamily="18" charset="0"/>
               </a:rPr>
               <a:t>ролі</a:t>
             </a:r>
             <a:r>
-              <a:rPr lang="ru-RU" sz="2200" dirty="0">
+              <a:rPr lang="ru-RU" sz="2000" dirty="0">
                 <a:latin typeface="Times New Roman" panose="02020603050405020304" pitchFamily="18" charset="0"/>
                 <a:cs typeface="Times New Roman" panose="02020603050405020304" pitchFamily="18" charset="0"/>
               </a:rPr>
               <a:t> </a:t>
             </a:r>
             <a:r>
-              <a:rPr lang="ru-RU" sz="2200" dirty="0" err="1">
+              <a:rPr lang="ru-RU" sz="2000" dirty="0" err="1">
                 <a:latin typeface="Times New Roman" panose="02020603050405020304" pitchFamily="18" charset="0"/>
                 <a:cs typeface="Times New Roman" panose="02020603050405020304" pitchFamily="18" charset="0"/>
               </a:rPr>
               <a:t>користувачів</a:t>
             </a:r>
             <a:r>
-              <a:rPr lang="ru-RU" sz="2200" dirty="0">
+              <a:rPr lang="ru-RU" sz="2000" dirty="0">
                 <a:latin typeface="Times New Roman" panose="02020603050405020304" pitchFamily="18" charset="0"/>
                 <a:cs typeface="Times New Roman" panose="02020603050405020304" pitchFamily="18" charset="0"/>
               </a:rPr>
@@ -11377,76 +11374,76 @@
               <a:buAutoNum type="arabicPeriod"/>
             </a:pPr>
             <a:r>
-              <a:rPr lang="ru-RU" sz="2200" dirty="0" err="1" smtClean="0">
+              <a:rPr lang="ru-RU" sz="2000" dirty="0" err="1" smtClean="0">
                 <a:latin typeface="Times New Roman" panose="02020603050405020304" pitchFamily="18" charset="0"/>
                 <a:cs typeface="Times New Roman" panose="02020603050405020304" pitchFamily="18" charset="0"/>
               </a:rPr>
               <a:t>Гість</a:t>
             </a:r>
             <a:r>
-              <a:rPr lang="ru-RU" sz="2200" dirty="0" smtClean="0">
+              <a:rPr lang="ru-RU" sz="2000" dirty="0" smtClean="0">
                 <a:latin typeface="Times New Roman" panose="02020603050405020304" pitchFamily="18" charset="0"/>
                 <a:cs typeface="Times New Roman" panose="02020603050405020304" pitchFamily="18" charset="0"/>
               </a:rPr>
               <a:t> — </a:t>
             </a:r>
             <a:r>
-              <a:rPr lang="ru-RU" sz="2200" dirty="0" err="1" smtClean="0">
+              <a:rPr lang="ru-RU" sz="2000" dirty="0" err="1" smtClean="0">
                 <a:latin typeface="Times New Roman" panose="02020603050405020304" pitchFamily="18" charset="0"/>
                 <a:cs typeface="Times New Roman" panose="02020603050405020304" pitchFamily="18" charset="0"/>
               </a:rPr>
               <a:t>сканує</a:t>
             </a:r>
             <a:r>
-              <a:rPr lang="ru-RU" sz="2200" dirty="0" smtClean="0">
+              <a:rPr lang="ru-RU" sz="2000" dirty="0" smtClean="0">
                 <a:latin typeface="Times New Roman" panose="02020603050405020304" pitchFamily="18" charset="0"/>
                 <a:cs typeface="Times New Roman" panose="02020603050405020304" pitchFamily="18" charset="0"/>
               </a:rPr>
               <a:t> </a:t>
             </a:r>
             <a:r>
-              <a:rPr lang="en-US" sz="2200" dirty="0" smtClean="0">
+              <a:rPr lang="en-US" sz="2000" dirty="0" smtClean="0">
                 <a:latin typeface="Times New Roman" panose="02020603050405020304" pitchFamily="18" charset="0"/>
                 <a:cs typeface="Times New Roman" panose="02020603050405020304" pitchFamily="18" charset="0"/>
               </a:rPr>
               <a:t>QR, </a:t>
             </a:r>
             <a:r>
-              <a:rPr lang="ru-RU" sz="2200" dirty="0" err="1" smtClean="0">
+              <a:rPr lang="ru-RU" sz="2000" dirty="0" err="1" smtClean="0">
                 <a:latin typeface="Times New Roman" panose="02020603050405020304" pitchFamily="18" charset="0"/>
                 <a:cs typeface="Times New Roman" panose="02020603050405020304" pitchFamily="18" charset="0"/>
               </a:rPr>
               <a:t>замовляє</a:t>
             </a:r>
             <a:r>
-              <a:rPr lang="ru-RU" sz="2200" dirty="0" smtClean="0">
+              <a:rPr lang="ru-RU" sz="2000" dirty="0" smtClean="0">
                 <a:latin typeface="Times New Roman" panose="02020603050405020304" pitchFamily="18" charset="0"/>
                 <a:cs typeface="Times New Roman" panose="02020603050405020304" pitchFamily="18" charset="0"/>
               </a:rPr>
               <a:t>, </a:t>
             </a:r>
             <a:r>
-              <a:rPr lang="ru-RU" sz="2200" dirty="0" err="1" smtClean="0">
+              <a:rPr lang="ru-RU" sz="2000" dirty="0" err="1" smtClean="0">
                 <a:latin typeface="Times New Roman" panose="02020603050405020304" pitchFamily="18" charset="0"/>
                 <a:cs typeface="Times New Roman" panose="02020603050405020304" pitchFamily="18" charset="0"/>
               </a:rPr>
               <a:t>відстежує</a:t>
             </a:r>
             <a:r>
-              <a:rPr lang="ru-RU" sz="2200" dirty="0" smtClean="0">
+              <a:rPr lang="ru-RU" sz="2000" dirty="0" smtClean="0">
                 <a:latin typeface="Times New Roman" panose="02020603050405020304" pitchFamily="18" charset="0"/>
                 <a:cs typeface="Times New Roman" panose="02020603050405020304" pitchFamily="18" charset="0"/>
               </a:rPr>
               <a:t> статус, </a:t>
             </a:r>
             <a:r>
-              <a:rPr lang="ru-RU" sz="2200" dirty="0" err="1" smtClean="0">
+              <a:rPr lang="ru-RU" sz="2000" dirty="0" err="1" smtClean="0">
                 <a:latin typeface="Times New Roman" panose="02020603050405020304" pitchFamily="18" charset="0"/>
                 <a:cs typeface="Times New Roman" panose="02020603050405020304" pitchFamily="18" charset="0"/>
               </a:rPr>
               <a:t>оплачує</a:t>
             </a:r>
-            <a:endParaRPr lang="ru-RU" sz="2200" dirty="0">
+            <a:endParaRPr lang="ru-RU" sz="2000" dirty="0">
               <a:latin typeface="Times New Roman" panose="02020603050405020304" pitchFamily="18" charset="0"/>
               <a:cs typeface="Times New Roman" panose="02020603050405020304" pitchFamily="18" charset="0"/>
             </a:endParaRPr>
@@ -11457,76 +11454,76 @@
               <a:buAutoNum type="arabicPeriod"/>
             </a:pPr>
             <a:r>
-              <a:rPr lang="ru-RU" sz="2200" dirty="0" smtClean="0">
+              <a:rPr lang="ru-RU" sz="2000" dirty="0" smtClean="0">
                 <a:latin typeface="Times New Roman" panose="02020603050405020304" pitchFamily="18" charset="0"/>
                 <a:cs typeface="Times New Roman" panose="02020603050405020304" pitchFamily="18" charset="0"/>
               </a:rPr>
               <a:t>Кухар — </a:t>
             </a:r>
             <a:r>
-              <a:rPr lang="en-US" sz="2200" dirty="0" smtClean="0">
+              <a:rPr lang="en-US" sz="2000" dirty="0" smtClean="0">
                 <a:latin typeface="Times New Roman" panose="02020603050405020304" pitchFamily="18" charset="0"/>
                 <a:cs typeface="Times New Roman" panose="02020603050405020304" pitchFamily="18" charset="0"/>
               </a:rPr>
               <a:t>KDS-</a:t>
             </a:r>
             <a:r>
-              <a:rPr lang="ru-RU" sz="2200" dirty="0" err="1" smtClean="0">
+              <a:rPr lang="ru-RU" sz="2000" dirty="0" err="1" smtClean="0">
                 <a:latin typeface="Times New Roman" panose="02020603050405020304" pitchFamily="18" charset="0"/>
                 <a:cs typeface="Times New Roman" panose="02020603050405020304" pitchFamily="18" charset="0"/>
               </a:rPr>
               <a:t>дошка</a:t>
             </a:r>
             <a:r>
-              <a:rPr lang="ru-RU" sz="2200" dirty="0" smtClean="0">
+              <a:rPr lang="ru-RU" sz="2000" dirty="0" smtClean="0">
                 <a:latin typeface="Times New Roman" panose="02020603050405020304" pitchFamily="18" charset="0"/>
                 <a:cs typeface="Times New Roman" panose="02020603050405020304" pitchFamily="18" charset="0"/>
               </a:rPr>
               <a:t> з </a:t>
             </a:r>
             <a:r>
-              <a:rPr lang="en-US" sz="2200" dirty="0" smtClean="0">
+              <a:rPr lang="en-US" sz="2000" dirty="0" smtClean="0">
                 <a:latin typeface="Times New Roman" panose="02020603050405020304" pitchFamily="18" charset="0"/>
                 <a:cs typeface="Times New Roman" panose="02020603050405020304" pitchFamily="18" charset="0"/>
               </a:rPr>
               <a:t>Kanban-</a:t>
             </a:r>
             <a:r>
-              <a:rPr lang="ru-RU" sz="2200" dirty="0" smtClean="0">
+              <a:rPr lang="ru-RU" sz="2000" dirty="0" smtClean="0">
                 <a:latin typeface="Times New Roman" panose="02020603050405020304" pitchFamily="18" charset="0"/>
                 <a:cs typeface="Times New Roman" panose="02020603050405020304" pitchFamily="18" charset="0"/>
               </a:rPr>
               <a:t>статусами </a:t>
             </a:r>
             <a:r>
-              <a:rPr lang="ru-RU" sz="2200" dirty="0" err="1" smtClean="0">
+              <a:rPr lang="ru-RU" sz="2000" dirty="0" err="1" smtClean="0">
                 <a:latin typeface="Times New Roman" panose="02020603050405020304" pitchFamily="18" charset="0"/>
                 <a:cs typeface="Times New Roman" panose="02020603050405020304" pitchFamily="18" charset="0"/>
               </a:rPr>
               <a:t>страв</a:t>
             </a:r>
             <a:r>
-              <a:rPr lang="ru-RU" sz="2200" dirty="0" smtClean="0">
+              <a:rPr lang="ru-RU" sz="2000" dirty="0" smtClean="0">
                 <a:latin typeface="Times New Roman" panose="02020603050405020304" pitchFamily="18" charset="0"/>
                 <a:cs typeface="Times New Roman" panose="02020603050405020304" pitchFamily="18" charset="0"/>
               </a:rPr>
               <a:t> у реальному </a:t>
             </a:r>
             <a:r>
-              <a:rPr lang="ru-RU" sz="2200" dirty="0" err="1" smtClean="0">
+              <a:rPr lang="ru-RU" sz="2000" dirty="0" err="1" smtClean="0">
                 <a:latin typeface="Times New Roman" panose="02020603050405020304" pitchFamily="18" charset="0"/>
                 <a:cs typeface="Times New Roman" panose="02020603050405020304" pitchFamily="18" charset="0"/>
               </a:rPr>
               <a:t>часі</a:t>
             </a:r>
             <a:r>
-              <a:rPr lang="ru-RU" sz="2200" dirty="0" smtClean="0">
+              <a:rPr lang="ru-RU" sz="2000" dirty="0" smtClean="0">
                 <a:latin typeface="Times New Roman" panose="02020603050405020304" pitchFamily="18" charset="0"/>
                 <a:cs typeface="Times New Roman" panose="02020603050405020304" pitchFamily="18" charset="0"/>
               </a:rPr>
               <a:t>, меню</a:t>
             </a:r>
-            <a:endParaRPr lang="ru-RU" sz="2200" dirty="0">
+            <a:endParaRPr lang="ru-RU" sz="2000" dirty="0">
               <a:latin typeface="Times New Roman" panose="02020603050405020304" pitchFamily="18" charset="0"/>
               <a:cs typeface="Times New Roman" panose="02020603050405020304" pitchFamily="18" charset="0"/>
             </a:endParaRPr>
@@ -11537,55 +11534,55 @@
               <a:buAutoNum type="arabicPeriod"/>
             </a:pPr>
             <a:r>
-              <a:rPr lang="ru-RU" sz="2200" dirty="0" err="1" smtClean="0">
+              <a:rPr lang="ru-RU" sz="2000" dirty="0" err="1" smtClean="0">
                 <a:latin typeface="Times New Roman" panose="02020603050405020304" pitchFamily="18" charset="0"/>
                 <a:cs typeface="Times New Roman" panose="02020603050405020304" pitchFamily="18" charset="0"/>
               </a:rPr>
               <a:t>Офіціант</a:t>
             </a:r>
             <a:r>
-              <a:rPr lang="ru-RU" sz="2200" dirty="0" smtClean="0">
+              <a:rPr lang="ru-RU" sz="2000" dirty="0" smtClean="0">
                 <a:latin typeface="Times New Roman" panose="02020603050405020304" pitchFamily="18" charset="0"/>
                 <a:cs typeface="Times New Roman" panose="02020603050405020304" pitchFamily="18" charset="0"/>
               </a:rPr>
               <a:t> — карта залу, </a:t>
             </a:r>
             <a:r>
-              <a:rPr lang="ru-RU" sz="2200" dirty="0" err="1" smtClean="0">
+              <a:rPr lang="ru-RU" sz="2000" dirty="0" err="1" smtClean="0">
                 <a:latin typeface="Times New Roman" panose="02020603050405020304" pitchFamily="18" charset="0"/>
                 <a:cs typeface="Times New Roman" panose="02020603050405020304" pitchFamily="18" charset="0"/>
               </a:rPr>
               <a:t>виклики</a:t>
             </a:r>
             <a:r>
-              <a:rPr lang="ru-RU" sz="2200" dirty="0" smtClean="0">
+              <a:rPr lang="ru-RU" sz="2000" dirty="0" smtClean="0">
                 <a:latin typeface="Times New Roman" panose="02020603050405020304" pitchFamily="18" charset="0"/>
                 <a:cs typeface="Times New Roman" panose="02020603050405020304" pitchFamily="18" charset="0"/>
               </a:rPr>
               <a:t>, </a:t>
             </a:r>
             <a:r>
-              <a:rPr lang="ru-RU" sz="2200" dirty="0" err="1" smtClean="0">
+              <a:rPr lang="ru-RU" sz="2000" dirty="0" err="1" smtClean="0">
                 <a:latin typeface="Times New Roman" panose="02020603050405020304" pitchFamily="18" charset="0"/>
                 <a:cs typeface="Times New Roman" panose="02020603050405020304" pitchFamily="18" charset="0"/>
               </a:rPr>
               <a:t>редагування</a:t>
             </a:r>
             <a:r>
-              <a:rPr lang="ru-RU" sz="2200" dirty="0" smtClean="0">
+              <a:rPr lang="ru-RU" sz="2000" dirty="0" smtClean="0">
                 <a:latin typeface="Times New Roman" panose="02020603050405020304" pitchFamily="18" charset="0"/>
                 <a:cs typeface="Times New Roman" panose="02020603050405020304" pitchFamily="18" charset="0"/>
               </a:rPr>
               <a:t> </a:t>
             </a:r>
             <a:r>
-              <a:rPr lang="ru-RU" sz="2200" dirty="0" err="1" smtClean="0">
+              <a:rPr lang="ru-RU" sz="2000" dirty="0" err="1" smtClean="0">
                 <a:latin typeface="Times New Roman" panose="02020603050405020304" pitchFamily="18" charset="0"/>
                 <a:cs typeface="Times New Roman" panose="02020603050405020304" pitchFamily="18" charset="0"/>
               </a:rPr>
               <a:t>замовлення</a:t>
             </a:r>
-            <a:endParaRPr lang="ru-RU" sz="2200" dirty="0">
+            <a:endParaRPr lang="ru-RU" sz="2000" dirty="0">
               <a:latin typeface="Times New Roman" panose="02020603050405020304" pitchFamily="18" charset="0"/>
               <a:cs typeface="Times New Roman" panose="02020603050405020304" pitchFamily="18" charset="0"/>
             </a:endParaRPr>
@@ -11596,55 +11593,55 @@
               <a:buAutoNum type="arabicPeriod"/>
             </a:pPr>
             <a:r>
-              <a:rPr lang="ru-RU" sz="2200" dirty="0" err="1" smtClean="0">
+              <a:rPr lang="ru-RU" sz="2000" dirty="0" err="1" smtClean="0">
                 <a:latin typeface="Times New Roman" panose="02020603050405020304" pitchFamily="18" charset="0"/>
                 <a:cs typeface="Times New Roman" panose="02020603050405020304" pitchFamily="18" charset="0"/>
               </a:rPr>
               <a:t>Адміністратор</a:t>
             </a:r>
             <a:r>
-              <a:rPr lang="ru-RU" sz="2200" dirty="0" smtClean="0">
+              <a:rPr lang="ru-RU" sz="2000" dirty="0" smtClean="0">
                 <a:latin typeface="Times New Roman" panose="02020603050405020304" pitchFamily="18" charset="0"/>
                 <a:cs typeface="Times New Roman" panose="02020603050405020304" pitchFamily="18" charset="0"/>
               </a:rPr>
               <a:t> — </a:t>
             </a:r>
             <a:r>
-              <a:rPr lang="ru-RU" sz="2200" dirty="0" err="1" smtClean="0">
+              <a:rPr lang="ru-RU" sz="2000" dirty="0" err="1" smtClean="0">
                 <a:latin typeface="Times New Roman" panose="02020603050405020304" pitchFamily="18" charset="0"/>
                 <a:cs typeface="Times New Roman" panose="02020603050405020304" pitchFamily="18" charset="0"/>
               </a:rPr>
               <a:t>повний</a:t>
             </a:r>
             <a:r>
-              <a:rPr lang="ru-RU" sz="2200" dirty="0" smtClean="0">
+              <a:rPr lang="ru-RU" sz="2000" dirty="0" smtClean="0">
                 <a:latin typeface="Times New Roman" panose="02020603050405020304" pitchFamily="18" charset="0"/>
                 <a:cs typeface="Times New Roman" panose="02020603050405020304" pitchFamily="18" charset="0"/>
               </a:rPr>
               <a:t> доступ: меню, персонал, </a:t>
             </a:r>
             <a:r>
-              <a:rPr lang="ru-RU" sz="2200" dirty="0" err="1" smtClean="0">
+              <a:rPr lang="ru-RU" sz="2000" dirty="0" err="1" smtClean="0">
                 <a:latin typeface="Times New Roman" panose="02020603050405020304" pitchFamily="18" charset="0"/>
                 <a:cs typeface="Times New Roman" panose="02020603050405020304" pitchFamily="18" charset="0"/>
               </a:rPr>
               <a:t>аналітика</a:t>
             </a:r>
             <a:r>
-              <a:rPr lang="ru-RU" sz="2200" dirty="0" smtClean="0">
+              <a:rPr lang="ru-RU" sz="2000" dirty="0" smtClean="0">
                 <a:latin typeface="Times New Roman" panose="02020603050405020304" pitchFamily="18" charset="0"/>
                 <a:cs typeface="Times New Roman" panose="02020603050405020304" pitchFamily="18" charset="0"/>
               </a:rPr>
               <a:t>, </a:t>
             </a:r>
             <a:r>
-              <a:rPr lang="ru-RU" sz="2200" dirty="0" err="1" smtClean="0">
+              <a:rPr lang="ru-RU" sz="2000" dirty="0" err="1" smtClean="0">
                 <a:latin typeface="Times New Roman" panose="02020603050405020304" pitchFamily="18" charset="0"/>
                 <a:cs typeface="Times New Roman" panose="02020603050405020304" pitchFamily="18" charset="0"/>
               </a:rPr>
               <a:t>налаштування</a:t>
             </a:r>
-            <a:endParaRPr lang="ru-RU" sz="2200" dirty="0" smtClean="0">
+            <a:endParaRPr lang="ru-RU" sz="2000" dirty="0" smtClean="0">
               <a:latin typeface="Times New Roman" panose="02020603050405020304" pitchFamily="18" charset="0"/>
               <a:cs typeface="Times New Roman" panose="02020603050405020304" pitchFamily="18" charset="0"/>
             </a:endParaRPr>
@@ -11656,28 +11653,28 @@
               </a:spcBef>
             </a:pPr>
             <a:r>
-              <a:rPr lang="ru-RU" sz="2200" dirty="0" smtClean="0">
+              <a:rPr lang="ru-RU" sz="2000" dirty="0" smtClean="0">
                 <a:latin typeface="Times New Roman" panose="02020603050405020304" pitchFamily="18" charset="0"/>
                 <a:cs typeface="Times New Roman" panose="02020603050405020304" pitchFamily="18" charset="0"/>
               </a:rPr>
               <a:t>Модель </a:t>
             </a:r>
             <a:r>
-              <a:rPr lang="ru-RU" sz="2200" dirty="0" err="1" smtClean="0">
+              <a:rPr lang="ru-RU" sz="2000" dirty="0" err="1" smtClean="0">
                 <a:latin typeface="Times New Roman" panose="02020603050405020304" pitchFamily="18" charset="0"/>
                 <a:cs typeface="Times New Roman" panose="02020603050405020304" pitchFamily="18" charset="0"/>
               </a:rPr>
               <a:t>монетизації</a:t>
             </a:r>
             <a:r>
-              <a:rPr lang="ru-RU" sz="2200" dirty="0" smtClean="0">
+              <a:rPr lang="ru-RU" sz="2000" dirty="0" smtClean="0">
                 <a:latin typeface="Times New Roman" panose="02020603050405020304" pitchFamily="18" charset="0"/>
                 <a:cs typeface="Times New Roman" panose="02020603050405020304" pitchFamily="18" charset="0"/>
               </a:rPr>
               <a:t> </a:t>
             </a:r>
             <a:r>
-              <a:rPr lang="en-US" sz="2200" dirty="0" smtClean="0">
+              <a:rPr lang="en-US" sz="2000" dirty="0" smtClean="0">
                 <a:latin typeface="Times New Roman" panose="02020603050405020304" pitchFamily="18" charset="0"/>
                 <a:cs typeface="Times New Roman" panose="02020603050405020304" pitchFamily="18" charset="0"/>
               </a:rPr>
@@ -11690,97 +11687,97 @@
               <a:buChar char="•"/>
             </a:pPr>
             <a:r>
-              <a:rPr lang="en-US" sz="2200" dirty="0" smtClean="0">
+              <a:rPr lang="en-US" sz="2000" dirty="0" smtClean="0">
                 <a:latin typeface="Times New Roman" panose="02020603050405020304" pitchFamily="18" charset="0"/>
                 <a:cs typeface="Times New Roman" panose="02020603050405020304" pitchFamily="18" charset="0"/>
               </a:rPr>
               <a:t>Free: QR-</a:t>
             </a:r>
             <a:r>
-              <a:rPr lang="ru-RU" sz="2200" dirty="0" smtClean="0">
+              <a:rPr lang="ru-RU" sz="2000" dirty="0" smtClean="0">
                 <a:latin typeface="Times New Roman" panose="02020603050405020304" pitchFamily="18" charset="0"/>
                 <a:cs typeface="Times New Roman" panose="02020603050405020304" pitchFamily="18" charset="0"/>
               </a:rPr>
               <a:t>меню, </a:t>
             </a:r>
             <a:r>
-              <a:rPr lang="en-US" sz="2200" dirty="0" smtClean="0">
+              <a:rPr lang="en-US" sz="2000" dirty="0" smtClean="0">
                 <a:latin typeface="Times New Roman" panose="02020603050405020304" pitchFamily="18" charset="0"/>
                 <a:cs typeface="Times New Roman" panose="02020603050405020304" pitchFamily="18" charset="0"/>
               </a:rPr>
               <a:t>KDS, </a:t>
             </a:r>
             <a:r>
-              <a:rPr lang="ru-RU" sz="2200" dirty="0" smtClean="0">
+              <a:rPr lang="ru-RU" sz="2000" dirty="0" smtClean="0">
                 <a:latin typeface="Times New Roman" panose="02020603050405020304" pitchFamily="18" charset="0"/>
                 <a:cs typeface="Times New Roman" panose="02020603050405020304" pitchFamily="18" charset="0"/>
               </a:rPr>
               <a:t>карта залу, </a:t>
             </a:r>
             <a:r>
-              <a:rPr lang="ru-RU" sz="2200" dirty="0" err="1" smtClean="0">
+              <a:rPr lang="ru-RU" sz="2000" dirty="0" err="1" smtClean="0">
                 <a:latin typeface="Times New Roman" panose="02020603050405020304" pitchFamily="18" charset="0"/>
                 <a:cs typeface="Times New Roman" panose="02020603050405020304" pitchFamily="18" charset="0"/>
               </a:rPr>
               <a:t>готівкова</a:t>
             </a:r>
             <a:r>
-              <a:rPr lang="ru-RU" sz="2200" dirty="0" smtClean="0">
+              <a:rPr lang="ru-RU" sz="2000" dirty="0" smtClean="0">
                 <a:latin typeface="Times New Roman" panose="02020603050405020304" pitchFamily="18" charset="0"/>
                 <a:cs typeface="Times New Roman" panose="02020603050405020304" pitchFamily="18" charset="0"/>
               </a:rPr>
               <a:t> оплата, до 50 </a:t>
             </a:r>
             <a:r>
-              <a:rPr lang="ru-RU" sz="2200" dirty="0" err="1" smtClean="0">
+              <a:rPr lang="ru-RU" sz="2000" dirty="0" err="1" smtClean="0">
                 <a:latin typeface="Times New Roman" panose="02020603050405020304" pitchFamily="18" charset="0"/>
                 <a:cs typeface="Times New Roman" panose="02020603050405020304" pitchFamily="18" charset="0"/>
               </a:rPr>
               <a:t>страв</a:t>
             </a:r>
             <a:r>
-              <a:rPr lang="en-US" sz="2200" dirty="0" smtClean="0">
+              <a:rPr lang="en-US" sz="2000" dirty="0" smtClean="0">
                 <a:latin typeface="Times New Roman" panose="02020603050405020304" pitchFamily="18" charset="0"/>
                 <a:cs typeface="Times New Roman" panose="02020603050405020304" pitchFamily="18" charset="0"/>
               </a:rPr>
               <a:t>, </a:t>
             </a:r>
             <a:r>
-              <a:rPr lang="ru-RU" sz="2200" dirty="0" smtClean="0">
+              <a:rPr lang="ru-RU" sz="2000" dirty="0" smtClean="0">
                 <a:latin typeface="Times New Roman" panose="02020603050405020304" pitchFamily="18" charset="0"/>
                 <a:cs typeface="Times New Roman" panose="02020603050405020304" pitchFamily="18" charset="0"/>
               </a:rPr>
               <a:t>до 5 </a:t>
             </a:r>
             <a:r>
-              <a:rPr lang="ru-RU" sz="2200" dirty="0" err="1" smtClean="0">
+              <a:rPr lang="ru-RU" sz="2000" dirty="0" err="1" smtClean="0">
                 <a:latin typeface="Times New Roman" panose="02020603050405020304" pitchFamily="18" charset="0"/>
                 <a:cs typeface="Times New Roman" panose="02020603050405020304" pitchFamily="18" charset="0"/>
               </a:rPr>
               <a:t>зображень</a:t>
             </a:r>
             <a:r>
-              <a:rPr lang="ru-RU" sz="2200" dirty="0" smtClean="0">
+              <a:rPr lang="ru-RU" sz="2000" dirty="0" smtClean="0">
                 <a:latin typeface="Times New Roman" panose="02020603050405020304" pitchFamily="18" charset="0"/>
                 <a:cs typeface="Times New Roman" panose="02020603050405020304" pitchFamily="18" charset="0"/>
               </a:rPr>
               <a:t>, до 3 </a:t>
             </a:r>
             <a:r>
-              <a:rPr lang="ru-RU" sz="2200" dirty="0" err="1" smtClean="0">
+              <a:rPr lang="ru-RU" sz="2000" dirty="0" err="1" smtClean="0">
                 <a:latin typeface="Times New Roman" panose="02020603050405020304" pitchFamily="18" charset="0"/>
                 <a:cs typeface="Times New Roman" panose="02020603050405020304" pitchFamily="18" charset="0"/>
               </a:rPr>
               <a:t>акаунтів</a:t>
             </a:r>
             <a:r>
-              <a:rPr lang="ru-RU" sz="2200" dirty="0" smtClean="0">
+              <a:rPr lang="ru-RU" sz="2000" dirty="0" smtClean="0">
                 <a:latin typeface="Times New Roman" panose="02020603050405020304" pitchFamily="18" charset="0"/>
                 <a:cs typeface="Times New Roman" panose="02020603050405020304" pitchFamily="18" charset="0"/>
               </a:rPr>
               <a:t> персоналу</a:t>
             </a:r>
-            <a:endParaRPr lang="en-US" sz="2200" dirty="0" smtClean="0">
+            <a:endParaRPr lang="en-US" sz="2000" dirty="0" smtClean="0">
               <a:latin typeface="Times New Roman" panose="02020603050405020304" pitchFamily="18" charset="0"/>
               <a:cs typeface="Times New Roman" panose="02020603050405020304" pitchFamily="18" charset="0"/>
             </a:endParaRPr>
@@ -11791,96 +11788,275 @@
               <a:buChar char="•"/>
             </a:pPr>
             <a:r>
-              <a:rPr lang="en-US" sz="2200" dirty="0" smtClean="0">
+              <a:rPr lang="en-US" sz="2000" dirty="0" smtClean="0">
                 <a:latin typeface="Times New Roman" panose="02020603050405020304" pitchFamily="18" charset="0"/>
                 <a:cs typeface="Times New Roman" panose="02020603050405020304" pitchFamily="18" charset="0"/>
               </a:rPr>
               <a:t>Premium: </a:t>
             </a:r>
             <a:r>
-              <a:rPr lang="ru-RU" sz="2200" dirty="0" smtClean="0">
+              <a:rPr lang="ru-RU" sz="2000" dirty="0" smtClean="0">
                 <a:latin typeface="Times New Roman" panose="02020603050405020304" pitchFamily="18" charset="0"/>
                 <a:cs typeface="Times New Roman" panose="02020603050405020304" pitchFamily="18" charset="0"/>
               </a:rPr>
               <a:t>онлайн-оплата </a:t>
             </a:r>
             <a:r>
-              <a:rPr lang="en-US" sz="2200" dirty="0" err="1" smtClean="0">
+              <a:rPr lang="en-US" sz="2000" dirty="0" err="1" smtClean="0">
                 <a:latin typeface="Times New Roman" panose="02020603050405020304" pitchFamily="18" charset="0"/>
                 <a:cs typeface="Times New Roman" panose="02020603050405020304" pitchFamily="18" charset="0"/>
               </a:rPr>
               <a:t>LiqPay</a:t>
             </a:r>
             <a:r>
-              <a:rPr lang="en-US" sz="2200" dirty="0" smtClean="0">
+              <a:rPr lang="en-US" sz="2000" dirty="0" smtClean="0">
                 <a:latin typeface="Times New Roman" panose="02020603050405020304" pitchFamily="18" charset="0"/>
                 <a:cs typeface="Times New Roman" panose="02020603050405020304" pitchFamily="18" charset="0"/>
               </a:rPr>
               <a:t>, </a:t>
             </a:r>
             <a:r>
-              <a:rPr lang="ru-RU" sz="2200" dirty="0" err="1" smtClean="0">
+              <a:rPr lang="ru-RU" sz="2000" dirty="0" err="1" smtClean="0">
                 <a:latin typeface="Times New Roman" panose="02020603050405020304" pitchFamily="18" charset="0"/>
                 <a:cs typeface="Times New Roman" panose="02020603050405020304" pitchFamily="18" charset="0"/>
               </a:rPr>
               <a:t>аналітика</a:t>
             </a:r>
             <a:r>
-              <a:rPr lang="ru-RU" sz="2200" dirty="0" smtClean="0">
+              <a:rPr lang="ru-RU" sz="2000" dirty="0" smtClean="0">
                 <a:latin typeface="Times New Roman" panose="02020603050405020304" pitchFamily="18" charset="0"/>
                 <a:cs typeface="Times New Roman" panose="02020603050405020304" pitchFamily="18" charset="0"/>
               </a:rPr>
               <a:t>, </a:t>
             </a:r>
             <a:r>
-              <a:rPr lang="en-US" sz="2200" dirty="0" smtClean="0">
+              <a:rPr lang="en-US" sz="2000" dirty="0" smtClean="0">
                 <a:latin typeface="Times New Roman" panose="02020603050405020304" pitchFamily="18" charset="0"/>
                 <a:cs typeface="Times New Roman" panose="02020603050405020304" pitchFamily="18" charset="0"/>
               </a:rPr>
               <a:t>PDF-</a:t>
             </a:r>
             <a:r>
-              <a:rPr lang="ru-RU" sz="2200" dirty="0" smtClean="0">
+              <a:rPr lang="ru-RU" sz="2000" dirty="0" smtClean="0">
                 <a:latin typeface="Times New Roman" panose="02020603050405020304" pitchFamily="18" charset="0"/>
                 <a:cs typeface="Times New Roman" panose="02020603050405020304" pitchFamily="18" charset="0"/>
               </a:rPr>
               <a:t>меню, </a:t>
             </a:r>
             <a:r>
-              <a:rPr lang="ru-RU" sz="2200" dirty="0" err="1" smtClean="0">
+              <a:rPr lang="ru-RU" sz="2000" dirty="0" err="1" smtClean="0">
                 <a:latin typeface="Times New Roman" panose="02020603050405020304" pitchFamily="18" charset="0"/>
                 <a:cs typeface="Times New Roman" panose="02020603050405020304" pitchFamily="18" charset="0"/>
               </a:rPr>
               <a:t>відгуки</a:t>
             </a:r>
             <a:r>
-              <a:rPr lang="ru-RU" sz="2200" dirty="0" smtClean="0">
+              <a:rPr lang="ru-RU" sz="2000" dirty="0" smtClean="0">
                 <a:latin typeface="Times New Roman" panose="02020603050405020304" pitchFamily="18" charset="0"/>
                 <a:cs typeface="Times New Roman" panose="02020603050405020304" pitchFamily="18" charset="0"/>
               </a:rPr>
               <a:t>, </a:t>
             </a:r>
             <a:r>
-              <a:rPr lang="en-US" sz="2200" dirty="0" smtClean="0">
+              <a:rPr lang="en-US" sz="2000" dirty="0" smtClean="0">
                 <a:latin typeface="Times New Roman" panose="02020603050405020304" pitchFamily="18" charset="0"/>
                 <a:cs typeface="Times New Roman" panose="02020603050405020304" pitchFamily="18" charset="0"/>
               </a:rPr>
               <a:t>Google Translate, </a:t>
             </a:r>
             <a:r>
-              <a:rPr lang="ru-RU" sz="2200" dirty="0" err="1" smtClean="0">
+              <a:rPr lang="ru-RU" sz="2000" dirty="0" err="1" smtClean="0">
                 <a:latin typeface="Times New Roman" panose="02020603050405020304" pitchFamily="18" charset="0"/>
                 <a:cs typeface="Times New Roman" panose="02020603050405020304" pitchFamily="18" charset="0"/>
               </a:rPr>
               <a:t>необмежено</a:t>
             </a:r>
-            <a:endParaRPr lang="ru-RU" sz="2200" dirty="0" smtClean="0">
+            <a:endParaRPr lang="ru-RU" sz="2000" dirty="0" smtClean="0">
               <a:latin typeface="Times New Roman" panose="02020603050405020304" pitchFamily="18" charset="0"/>
               <a:cs typeface="Times New Roman" panose="02020603050405020304" pitchFamily="18" charset="0"/>
             </a:endParaRPr>
           </a:p>
           <a:p>
-            <a:endParaRPr lang="en-US" sz="2200" dirty="0">
+            <a:pPr>
+              <a:spcBef>
+                <a:spcPts val="1800"/>
+              </a:spcBef>
+            </a:pPr>
+            <a:r>
+              <a:rPr lang="ru-RU" sz="2000" dirty="0" err="1">
+                <a:latin typeface="Times New Roman" panose="02020603050405020304" pitchFamily="18" charset="0"/>
+                <a:cs typeface="Times New Roman" panose="02020603050405020304" pitchFamily="18" charset="0"/>
+              </a:rPr>
+              <a:t>Архітектура</a:t>
+            </a:r>
+            <a:r>
+              <a:rPr lang="ru-RU" sz="2000" dirty="0">
+                <a:latin typeface="Times New Roman" panose="02020603050405020304" pitchFamily="18" charset="0"/>
+                <a:cs typeface="Times New Roman" panose="02020603050405020304" pitchFamily="18" charset="0"/>
+              </a:rPr>
+              <a:t>: </a:t>
+            </a:r>
+            <a:r>
+              <a:rPr lang="en-US" sz="2000" dirty="0">
+                <a:latin typeface="Times New Roman" panose="02020603050405020304" pitchFamily="18" charset="0"/>
+                <a:cs typeface="Times New Roman" panose="02020603050405020304" pitchFamily="18" charset="0"/>
+              </a:rPr>
+              <a:t>multi-tenant SaaS — </a:t>
+            </a:r>
+            <a:r>
+              <a:rPr lang="ru-RU" sz="2000" dirty="0">
+                <a:latin typeface="Times New Roman" panose="02020603050405020304" pitchFamily="18" charset="0"/>
+                <a:cs typeface="Times New Roman" panose="02020603050405020304" pitchFamily="18" charset="0"/>
+              </a:rPr>
+              <a:t>одна </a:t>
+            </a:r>
+            <a:r>
+              <a:rPr lang="ru-RU" sz="2000" dirty="0" err="1">
+                <a:latin typeface="Times New Roman" panose="02020603050405020304" pitchFamily="18" charset="0"/>
+                <a:cs typeface="Times New Roman" panose="02020603050405020304" pitchFamily="18" charset="0"/>
+              </a:rPr>
+              <a:t>інстанція</a:t>
+            </a:r>
+            <a:r>
+              <a:rPr lang="ru-RU" sz="2000" dirty="0">
+                <a:latin typeface="Times New Roman" panose="02020603050405020304" pitchFamily="18" charset="0"/>
+                <a:cs typeface="Times New Roman" panose="02020603050405020304" pitchFamily="18" charset="0"/>
+              </a:rPr>
+              <a:t> </a:t>
+            </a:r>
+            <a:r>
+              <a:rPr lang="ru-RU" sz="2000" dirty="0" err="1">
+                <a:latin typeface="Times New Roman" panose="02020603050405020304" pitchFamily="18" charset="0"/>
+                <a:cs typeface="Times New Roman" panose="02020603050405020304" pitchFamily="18" charset="0"/>
+              </a:rPr>
+              <a:t>системи</a:t>
+            </a:r>
+            <a:r>
+              <a:rPr lang="ru-RU" sz="2000" dirty="0">
+                <a:latin typeface="Times New Roman" panose="02020603050405020304" pitchFamily="18" charset="0"/>
+                <a:cs typeface="Times New Roman" panose="02020603050405020304" pitchFamily="18" charset="0"/>
+              </a:rPr>
+              <a:t> </a:t>
+            </a:r>
+            <a:r>
+              <a:rPr lang="ru-RU" sz="2000" dirty="0" err="1">
+                <a:latin typeface="Times New Roman" panose="02020603050405020304" pitchFamily="18" charset="0"/>
+                <a:cs typeface="Times New Roman" panose="02020603050405020304" pitchFamily="18" charset="0"/>
+              </a:rPr>
+              <a:t>обслуговує</a:t>
+            </a:r>
+            <a:r>
+              <a:rPr lang="ru-RU" sz="2000" dirty="0">
+                <a:latin typeface="Times New Roman" panose="02020603050405020304" pitchFamily="18" charset="0"/>
+                <a:cs typeface="Times New Roman" panose="02020603050405020304" pitchFamily="18" charset="0"/>
+              </a:rPr>
+              <a:t> </a:t>
+            </a:r>
+            <a:r>
+              <a:rPr lang="ru-RU" sz="2000" dirty="0" err="1">
+                <a:latin typeface="Times New Roman" panose="02020603050405020304" pitchFamily="18" charset="0"/>
+                <a:cs typeface="Times New Roman" panose="02020603050405020304" pitchFamily="18" charset="0"/>
+              </a:rPr>
+              <a:t>необмежену</a:t>
+            </a:r>
+            <a:r>
+              <a:rPr lang="ru-RU" sz="2000" dirty="0">
+                <a:latin typeface="Times New Roman" panose="02020603050405020304" pitchFamily="18" charset="0"/>
+                <a:cs typeface="Times New Roman" panose="02020603050405020304" pitchFamily="18" charset="0"/>
+              </a:rPr>
+              <a:t> </a:t>
+            </a:r>
+            <a:r>
+              <a:rPr lang="ru-RU" sz="2000" dirty="0" err="1">
+                <a:latin typeface="Times New Roman" panose="02020603050405020304" pitchFamily="18" charset="0"/>
+                <a:cs typeface="Times New Roman" panose="02020603050405020304" pitchFamily="18" charset="0"/>
+              </a:rPr>
+              <a:t>кількість</a:t>
+            </a:r>
+            <a:r>
+              <a:rPr lang="ru-RU" sz="2000" dirty="0">
+                <a:latin typeface="Times New Roman" panose="02020603050405020304" pitchFamily="18" charset="0"/>
+                <a:cs typeface="Times New Roman" panose="02020603050405020304" pitchFamily="18" charset="0"/>
+              </a:rPr>
+              <a:t> </a:t>
+            </a:r>
+            <a:r>
+              <a:rPr lang="ru-RU" sz="2000" dirty="0" err="1">
+                <a:latin typeface="Times New Roman" panose="02020603050405020304" pitchFamily="18" charset="0"/>
+                <a:cs typeface="Times New Roman" panose="02020603050405020304" pitchFamily="18" charset="0"/>
+              </a:rPr>
+              <a:t>ресторанів</a:t>
+            </a:r>
+            <a:r>
+              <a:rPr lang="ru-RU" sz="2000" dirty="0">
+                <a:latin typeface="Times New Roman" panose="02020603050405020304" pitchFamily="18" charset="0"/>
+                <a:cs typeface="Times New Roman" panose="02020603050405020304" pitchFamily="18" charset="0"/>
+              </a:rPr>
+              <a:t> з </a:t>
+            </a:r>
+            <a:r>
+              <a:rPr lang="ru-RU" sz="2000" dirty="0" err="1">
+                <a:latin typeface="Times New Roman" panose="02020603050405020304" pitchFamily="18" charset="0"/>
+                <a:cs typeface="Times New Roman" panose="02020603050405020304" pitchFamily="18" charset="0"/>
+              </a:rPr>
+              <a:t>повною</a:t>
+            </a:r>
+            <a:r>
+              <a:rPr lang="ru-RU" sz="2000" dirty="0">
+                <a:latin typeface="Times New Roman" panose="02020603050405020304" pitchFamily="18" charset="0"/>
+                <a:cs typeface="Times New Roman" panose="02020603050405020304" pitchFamily="18" charset="0"/>
+              </a:rPr>
+              <a:t> </a:t>
+            </a:r>
+            <a:r>
+              <a:rPr lang="ru-RU" sz="2000" dirty="0" err="1">
+                <a:latin typeface="Times New Roman" panose="02020603050405020304" pitchFamily="18" charset="0"/>
+                <a:cs typeface="Times New Roman" panose="02020603050405020304" pitchFamily="18" charset="0"/>
+              </a:rPr>
+              <a:t>ізоляцією</a:t>
+            </a:r>
+            <a:r>
+              <a:rPr lang="ru-RU" sz="2000" dirty="0">
+                <a:latin typeface="Times New Roman" panose="02020603050405020304" pitchFamily="18" charset="0"/>
+                <a:cs typeface="Times New Roman" panose="02020603050405020304" pitchFamily="18" charset="0"/>
+              </a:rPr>
+              <a:t> </a:t>
+            </a:r>
+            <a:r>
+              <a:rPr lang="ru-RU" sz="2000" dirty="0" err="1">
+                <a:latin typeface="Times New Roman" panose="02020603050405020304" pitchFamily="18" charset="0"/>
+                <a:cs typeface="Times New Roman" panose="02020603050405020304" pitchFamily="18" charset="0"/>
+              </a:rPr>
+              <a:t>даних</a:t>
+            </a:r>
+            <a:r>
+              <a:rPr lang="ru-RU" sz="2000" dirty="0">
+                <a:latin typeface="Times New Roman" panose="02020603050405020304" pitchFamily="18" charset="0"/>
+                <a:cs typeface="Times New Roman" panose="02020603050405020304" pitchFamily="18" charset="0"/>
+              </a:rPr>
+              <a:t> </a:t>
+            </a:r>
+            <a:r>
+              <a:rPr lang="ru-RU" sz="2000" dirty="0" err="1">
+                <a:latin typeface="Times New Roman" panose="02020603050405020304" pitchFamily="18" charset="0"/>
+                <a:cs typeface="Times New Roman" panose="02020603050405020304" pitchFamily="18" charset="0"/>
+              </a:rPr>
+              <a:t>між</a:t>
+            </a:r>
+            <a:r>
+              <a:rPr lang="ru-RU" sz="2000" dirty="0">
+                <a:latin typeface="Times New Roman" panose="02020603050405020304" pitchFamily="18" charset="0"/>
+                <a:cs typeface="Times New Roman" panose="02020603050405020304" pitchFamily="18" charset="0"/>
+              </a:rPr>
+              <a:t> ними.</a:t>
+            </a:r>
+            <a:endParaRPr lang="ru-RU" sz="2000" dirty="0" smtClean="0">
+              <a:latin typeface="Times New Roman" panose="02020603050405020304" pitchFamily="18" charset="0"/>
+              <a:cs typeface="Times New Roman" panose="02020603050405020304" pitchFamily="18" charset="0"/>
+            </a:endParaRPr>
+          </a:p>
+          <a:p>
+            <a:endParaRPr lang="en-US" sz="2000" dirty="0">
               <a:latin typeface="Times New Roman" panose="02020603050405020304" pitchFamily="18" charset="0"/>
               <a:cs typeface="Times New Roman" panose="02020603050405020304" pitchFamily="18" charset="0"/>
             </a:endParaRPr>
@@ -11895,7 +12071,7 @@
         </p:nvSpPr>
         <p:spPr>
           <a:xfrm>
-            <a:off x="1301910" y="649791"/>
+            <a:off x="1301910" y="493374"/>
             <a:ext cx="9588174" cy="679673"/>
           </a:xfrm>
           <a:prstGeom prst="rect">
@@ -12369,39 +12545,39 @@
           <a:lstStyle/>
           <a:p>
             <a:r>
+              <a:rPr lang="en-US" sz="2400" dirty="0">
+                <a:latin typeface="Times New Roman" panose="02020603050405020304" pitchFamily="18" charset="0"/>
+                <a:cs typeface="Times New Roman" panose="02020603050405020304" pitchFamily="18" charset="0"/>
+              </a:rPr>
+              <a:t>Backend: Node.js 18 LTS, Express.js, </a:t>
+            </a:r>
+            <a:r>
+              <a:rPr lang="en-US" sz="2400" dirty="0" err="1">
+                <a:latin typeface="Times New Roman" panose="02020603050405020304" pitchFamily="18" charset="0"/>
+                <a:cs typeface="Times New Roman" panose="02020603050405020304" pitchFamily="18" charset="0"/>
+              </a:rPr>
+              <a:t>WebSocket</a:t>
+            </a:r>
+            <a:r>
+              <a:rPr lang="en-US" sz="2400" dirty="0">
+                <a:latin typeface="Times New Roman" panose="02020603050405020304" pitchFamily="18" charset="0"/>
+                <a:cs typeface="Times New Roman" panose="02020603050405020304" pitchFamily="18" charset="0"/>
+              </a:rPr>
+              <a:t> (</a:t>
+            </a:r>
+            <a:r>
+              <a:rPr lang="en-US" sz="2400" dirty="0" err="1">
+                <a:latin typeface="Times New Roman" panose="02020603050405020304" pitchFamily="18" charset="0"/>
+                <a:cs typeface="Times New Roman" panose="02020603050405020304" pitchFamily="18" charset="0"/>
+              </a:rPr>
+              <a:t>ws</a:t>
+            </a:r>
+            <a:r>
               <a:rPr lang="en-US" sz="2400" dirty="0" smtClean="0">
                 <a:latin typeface="Times New Roman" panose="02020603050405020304" pitchFamily="18" charset="0"/>
                 <a:cs typeface="Times New Roman" panose="02020603050405020304" pitchFamily="18" charset="0"/>
               </a:rPr>
-              <a:t>Frontend: </a:t>
-            </a:r>
-            <a:r>
-              <a:rPr lang="en-US" sz="2400" dirty="0" err="1" smtClean="0">
-                <a:latin typeface="Times New Roman" panose="02020603050405020304" pitchFamily="18" charset="0"/>
-                <a:cs typeface="Times New Roman" panose="02020603050405020304" pitchFamily="18" charset="0"/>
-              </a:rPr>
-              <a:t>ReactJS</a:t>
-            </a:r>
-            <a:r>
-              <a:rPr lang="en-US" sz="2400" dirty="0" smtClean="0">
-                <a:latin typeface="Times New Roman" panose="02020603050405020304" pitchFamily="18" charset="0"/>
-                <a:cs typeface="Times New Roman" panose="02020603050405020304" pitchFamily="18" charset="0"/>
-              </a:rPr>
-              <a:t> 18 (SPA/PWA), </a:t>
-            </a:r>
-            <a:r>
-              <a:rPr lang="en-US" sz="2400" dirty="0" err="1" smtClean="0">
-                <a:latin typeface="Times New Roman" panose="02020603050405020304" pitchFamily="18" charset="0"/>
-                <a:cs typeface="Times New Roman" panose="02020603050405020304" pitchFamily="18" charset="0"/>
-              </a:rPr>
-              <a:t>Vite</a:t>
-            </a:r>
-            <a:r>
-              <a:rPr lang="en-US" sz="2400" dirty="0" smtClean="0">
-                <a:latin typeface="Times New Roman" panose="02020603050405020304" pitchFamily="18" charset="0"/>
-                <a:cs typeface="Times New Roman" panose="02020603050405020304" pitchFamily="18" charset="0"/>
-              </a:rPr>
-              <a:t>, i18next</a:t>
+              <a:t>)</a:t>
             </a:r>
             <a:endParaRPr lang="uk-UA" sz="2400" dirty="0" smtClean="0">
               <a:latin typeface="Times New Roman" panose="02020603050405020304" pitchFamily="18" charset="0"/>
@@ -12414,35 +12590,35 @@
                 <a:latin typeface="Times New Roman" panose="02020603050405020304" pitchFamily="18" charset="0"/>
                 <a:cs typeface="Times New Roman" panose="02020603050405020304" pitchFamily="18" charset="0"/>
               </a:rPr>
-              <a:t>Backend: Node.js 18 LTS, Express.js, </a:t>
+              <a:t>Frontend: </a:t>
             </a:r>
             <a:r>
               <a:rPr lang="en-US" sz="2400" dirty="0" err="1" smtClean="0">
                 <a:latin typeface="Times New Roman" panose="02020603050405020304" pitchFamily="18" charset="0"/>
                 <a:cs typeface="Times New Roman" panose="02020603050405020304" pitchFamily="18" charset="0"/>
               </a:rPr>
-              <a:t>WebSocket</a:t>
+              <a:t>ReactJS</a:t>
             </a:r>
             <a:r>
               <a:rPr lang="en-US" sz="2400" dirty="0" smtClean="0">
                 <a:latin typeface="Times New Roman" panose="02020603050405020304" pitchFamily="18" charset="0"/>
                 <a:cs typeface="Times New Roman" panose="02020603050405020304" pitchFamily="18" charset="0"/>
               </a:rPr>
-              <a:t> (</a:t>
+              <a:t> 18 (SPA/PWA), </a:t>
             </a:r>
             <a:r>
               <a:rPr lang="en-US" sz="2400" dirty="0" err="1" smtClean="0">
                 <a:latin typeface="Times New Roman" panose="02020603050405020304" pitchFamily="18" charset="0"/>
                 <a:cs typeface="Times New Roman" panose="02020603050405020304" pitchFamily="18" charset="0"/>
               </a:rPr>
-              <a:t>ws</a:t>
+              <a:t>Vite</a:t>
             </a:r>
             <a:r>
               <a:rPr lang="en-US" sz="2400" dirty="0" smtClean="0">
                 <a:latin typeface="Times New Roman" panose="02020603050405020304" pitchFamily="18" charset="0"/>
                 <a:cs typeface="Times New Roman" panose="02020603050405020304" pitchFamily="18" charset="0"/>
               </a:rPr>
-              <a:t>)</a:t>
+              <a:t>, i18next</a:t>
             </a:r>
             <a:endParaRPr lang="uk-UA" sz="2400" dirty="0" smtClean="0">
               <a:latin typeface="Times New Roman" panose="02020603050405020304" pitchFamily="18" charset="0"/>
@@ -13587,8 +13763,8 @@
         </p:nvGrpSpPr>
         <p:grpSpPr>
           <a:xfrm>
-            <a:off x="1" y="261258"/>
-            <a:ext cx="11916228" cy="6505302"/>
+            <a:off x="153909" y="261258"/>
+            <a:ext cx="11762320" cy="6505302"/>
             <a:chOff x="0" y="0"/>
             <a:chExt cx="4274335" cy="2167467"/>
           </a:xfrm>
@@ -13722,7 +13898,7 @@
         </p:nvSpPr>
         <p:spPr>
           <a:xfrm rot="4481473">
-            <a:off x="-3527441" y="-4197375"/>
+            <a:off x="-3612874" y="-4333178"/>
             <a:ext cx="5748994" cy="5833850"/>
           </a:xfrm>
           <a:custGeom>
@@ -13774,7 +13950,7 @@
         </p:nvSpPr>
         <p:spPr>
           <a:xfrm>
-            <a:off x="0" y="745041"/>
+            <a:off x="329066" y="257524"/>
             <a:ext cx="4886325" cy="2035286"/>
           </a:xfrm>
           <a:prstGeom prst="rect">
@@ -13931,8 +14107,8 @@
         </p:blipFill>
         <p:spPr>
           <a:xfrm>
-            <a:off x="575043" y="2801639"/>
-            <a:ext cx="3752206" cy="3472634"/>
+            <a:off x="329066" y="2941683"/>
+            <a:ext cx="3752206" cy="3468378"/>
           </a:xfrm>
           <a:prstGeom prst="rect">
             <a:avLst/>
@@ -13952,7 +14128,7 @@
         </p:nvSpPr>
         <p:spPr>
           <a:xfrm>
-            <a:off x="551884" y="5969024"/>
+            <a:off x="168641" y="6106978"/>
             <a:ext cx="3798524" cy="557845"/>
           </a:xfrm>
           <a:prstGeom prst="rect">

</xml_diff>